<commit_message>
final discussion - hyst.
</commit_message>
<xml_diff>
--- a/Presentation/Final_results.pptx
+++ b/Presentation/Final_results.pptx
@@ -211,7 +211,7 @@
           <a:p>
             <a:fld id="{5BF05510-8F20-4855-92F5-1C6E04172244}" type="datetimeFigureOut">
               <a:rPr lang="it-IT" smtClean="0"/>
-              <a:t>02/02/2026</a:t>
+              <a:t>03/02/2026</a:t>
             </a:fld>
             <a:endParaRPr lang="it-IT"/>
           </a:p>
@@ -3606,7 +3606,7 @@
           <a:p>
             <a:fld id="{B1A456F9-5324-E24F-B3F0-0DBA7E0CFF8E}" type="datetimeFigureOut">
               <a:rPr lang="it-IT" smtClean="0"/>
-              <a:t>02/02/2026</a:t>
+              <a:t>03/02/2026</a:t>
             </a:fld>
             <a:endParaRPr lang="it-IT"/>
           </a:p>
@@ -3804,7 +3804,7 @@
           <a:p>
             <a:fld id="{B1A456F9-5324-E24F-B3F0-0DBA7E0CFF8E}" type="datetimeFigureOut">
               <a:rPr lang="it-IT" smtClean="0"/>
-              <a:t>02/02/2026</a:t>
+              <a:t>03/02/2026</a:t>
             </a:fld>
             <a:endParaRPr lang="it-IT"/>
           </a:p>
@@ -9249,14 +9249,14 @@
           <p:nvPr>
             <p:extLst>
               <p:ext uri="{D42A27DB-BD31-4B8C-83A1-F6EECF244321}">
-                <p14:modId xmlns:p14="http://schemas.microsoft.com/office/powerpoint/2010/main" val="1242973611"/>
+                <p14:modId xmlns:p14="http://schemas.microsoft.com/office/powerpoint/2010/main" val="1650713939"/>
               </p:ext>
             </p:extLst>
           </p:nvPr>
         </p:nvGraphicFramePr>
         <p:xfrm>
           <a:off x="2032000" y="4490282"/>
-          <a:ext cx="8127999" cy="1483360"/>
+          <a:ext cx="8983932" cy="1854200"/>
         </p:xfrm>
         <a:graphic>
           <a:graphicData uri="http://schemas.openxmlformats.org/drawingml/2006/table">
@@ -9265,24 +9265,31 @@
                 <a:tableStyleId>{5C22544A-7EE6-4342-B048-85BDC9FD1C3A}</a:tableStyleId>
               </a:tblPr>
               <a:tblGrid>
-                <a:gridCol w="2709333">
+                <a:gridCol w="2245983">
                   <a:extLst>
                     <a:ext uri="{9D8B030D-6E8A-4147-A177-3AD203B41FA5}">
                       <a16:colId xmlns:a16="http://schemas.microsoft.com/office/drawing/2014/main" val="3229643532"/>
                     </a:ext>
                   </a:extLst>
                 </a:gridCol>
-                <a:gridCol w="2709333">
+                <a:gridCol w="2245983">
                   <a:extLst>
                     <a:ext uri="{9D8B030D-6E8A-4147-A177-3AD203B41FA5}">
                       <a16:colId xmlns:a16="http://schemas.microsoft.com/office/drawing/2014/main" val="3631733379"/>
                     </a:ext>
                   </a:extLst>
                 </a:gridCol>
-                <a:gridCol w="2709333">
+                <a:gridCol w="2245983">
                   <a:extLst>
                     <a:ext uri="{9D8B030D-6E8A-4147-A177-3AD203B41FA5}">
                       <a16:colId xmlns:a16="http://schemas.microsoft.com/office/drawing/2014/main" val="1988245663"/>
+                    </a:ext>
+                  </a:extLst>
+                </a:gridCol>
+                <a:gridCol w="2245983">
+                  <a:extLst>
+                    <a:ext uri="{9D8B030D-6E8A-4147-A177-3AD203B41FA5}">
+                      <a16:colId xmlns:a16="http://schemas.microsoft.com/office/drawing/2014/main" val="91464698"/>
                     </a:ext>
                   </a:extLst>
                 </a:gridCol>
@@ -9333,6 +9340,21 @@
                   </a:txBody>
                   <a:tcPr/>
                 </a:tc>
+                <a:tc>
+                  <a:txBody>
+                    <a:bodyPr/>
+                    <a:lstStyle/>
+                    <a:p>
+                      <a:pPr algn="ctr"/>
+                      <a:r>
+                        <a:rPr lang="en-GB" noProof="0" dirty="0" err="1"/>
+                        <a:t>E_out</a:t>
+                      </a:r>
+                      <a:endParaRPr lang="en-GB" noProof="0" dirty="0"/>
+                    </a:p>
+                  </a:txBody>
+                  <a:tcPr/>
+                </a:tc>
                 <a:extLst>
                   <a:ext uri="{0D108BD9-81ED-4DB2-BD59-A6C34878D82A}">
                     <a16:rowId xmlns:a16="http://schemas.microsoft.com/office/drawing/2014/main" val="2304902295"/>
@@ -9347,10 +9369,9 @@
                     <a:p>
                       <a:pPr algn="ctr"/>
                       <a:r>
-                        <a:rPr lang="en-GB" noProof="0"/>
-                        <a:t>50 mV</a:t>
+                        <a:rPr lang="en-GB" noProof="0" dirty="0"/>
+                        <a:t>20 mV(no res.)</a:t>
                       </a:r>
-                      <a:endParaRPr lang="en-GB" noProof="0" dirty="0"/>
                     </a:p>
                   </a:txBody>
                   <a:tcPr/>
@@ -9363,7 +9384,70 @@
                       <a:pPr algn="ctr"/>
                       <a:r>
                         <a:rPr lang="en-GB" noProof="0" dirty="0"/>
-                        <a:t>65,8%</a:t>
+                        <a:t>64,5 %</a:t>
+                      </a:r>
+                    </a:p>
+                  </a:txBody>
+                  <a:tcPr/>
+                </a:tc>
+                <a:tc>
+                  <a:txBody>
+                    <a:bodyPr/>
+                    <a:lstStyle/>
+                    <a:p>
+                      <a:pPr algn="ctr"/>
+                      <a:r>
+                        <a:rPr lang="en-GB" noProof="0" dirty="0"/>
+                        <a:t>12,5 J</a:t>
+                      </a:r>
+                    </a:p>
+                  </a:txBody>
+                  <a:tcPr/>
+                </a:tc>
+                <a:tc>
+                  <a:txBody>
+                    <a:bodyPr/>
+                    <a:lstStyle/>
+                    <a:p>
+                      <a:pPr algn="ctr"/>
+                      <a:r>
+                        <a:rPr lang="en-GB" noProof="0" dirty="0"/>
+                        <a:t>7,88 J</a:t>
+                      </a:r>
+                    </a:p>
+                  </a:txBody>
+                  <a:tcPr/>
+                </a:tc>
+                <a:extLst>
+                  <a:ext uri="{0D108BD9-81ED-4DB2-BD59-A6C34878D82A}">
+                    <a16:rowId xmlns:a16="http://schemas.microsoft.com/office/drawing/2014/main" val="687645067"/>
+                  </a:ext>
+                </a:extLst>
+              </a:tr>
+              <a:tr h="370840">
+                <a:tc>
+                  <a:txBody>
+                    <a:bodyPr/>
+                    <a:lstStyle/>
+                    <a:p>
+                      <a:pPr algn="ctr"/>
+                      <a:r>
+                        <a:rPr lang="en-GB" noProof="0" dirty="0"/>
+                        <a:t>50 mV</a:t>
+                      </a:r>
+                    </a:p>
+                  </a:txBody>
+                  <a:tcPr/>
+                </a:tc>
+                <a:tc>
+                  <a:txBody>
+                    <a:bodyPr/>
+                    <a:lstStyle/>
+                    <a:p>
+                      <a:pPr algn="ctr"/>
+                      <a:r>
+                        <a:rPr lang="en-GB" noProof="0" dirty="0"/>
+                        <a:t>65,8 %</a:t>
                       </a:r>
                     </a:p>
                   </a:txBody>
@@ -9378,6 +9462,20 @@
                       <a:r>
                         <a:rPr lang="en-GB" noProof="0" dirty="0"/>
                         <a:t>12,3 J</a:t>
+                      </a:r>
+                    </a:p>
+                  </a:txBody>
+                  <a:tcPr/>
+                </a:tc>
+                <a:tc>
+                  <a:txBody>
+                    <a:bodyPr/>
+                    <a:lstStyle/>
+                    <a:p>
+                      <a:pPr algn="ctr"/>
+                      <a:r>
+                        <a:rPr lang="en-GB" noProof="0" dirty="0"/>
+                        <a:t>7,90 J</a:t>
                       </a:r>
                     </a:p>
                   </a:txBody>
@@ -9432,6 +9530,20 @@
                   </a:txBody>
                   <a:tcPr/>
                 </a:tc>
+                <a:tc>
+                  <a:txBody>
+                    <a:bodyPr/>
+                    <a:lstStyle/>
+                    <a:p>
+                      <a:pPr algn="ctr"/>
+                      <a:r>
+                        <a:rPr lang="en-GB" noProof="0" dirty="0"/>
+                        <a:t>7,09 J</a:t>
+                      </a:r>
+                    </a:p>
+                  </a:txBody>
+                  <a:tcPr/>
+                </a:tc>
                 <a:extLst>
                   <a:ext uri="{0D108BD9-81ED-4DB2-BD59-A6C34878D82A}">
                     <a16:rowId xmlns:a16="http://schemas.microsoft.com/office/drawing/2014/main" val="1070545901"/>
@@ -9477,6 +9589,21 @@
                         <a:rPr lang="en-GB" noProof="0" dirty="0"/>
                         <a:t>9,9 J</a:t>
                       </a:r>
+                    </a:p>
+                  </a:txBody>
+                  <a:tcPr/>
+                </a:tc>
+                <a:tc>
+                  <a:txBody>
+                    <a:bodyPr/>
+                    <a:lstStyle/>
+                    <a:p>
+                      <a:pPr algn="ctr"/>
+                      <a:r>
+                        <a:rPr lang="en-GB" noProof="0"/>
+                        <a:t>6,47 J</a:t>
+                      </a:r>
+                      <a:endParaRPr lang="en-GB" noProof="0" dirty="0"/>
                     </a:p>
                   </a:txBody>
                   <a:tcPr/>

</xml_diff>